<commit_message>
Stage 3 steps 3 and 4 results; sync notes, Gantt, deck and README to October 19
Co-Authored-By: Claude Opus 5.5 <noreply@anthropic.com>

Claude-Session: https://claude.ai/code/session_01A54DUp2K2ADqzEJ7zvsPHg
</commit_message>
<xml_diff>
--- a/docs/Research_Project_Plan_Gantt.pptx
+++ b/docs/Research_Project_Plan_Gantt.pptx
@@ -8323,7 +8323,7 @@
                 <a:ea typeface="Arial"/>
                 <a:cs typeface="Arial"/>
               </a:rPr>
-              <a:t>As of Oct 15, 2026</a:t>
+              <a:t>As of Oct 19, 2026</a:t>
             </a:r>
           </a:p>
         </p:txBody>
@@ -32436,7 +32436,7 @@
                 <a:ea typeface="Arial"/>
                 <a:cs typeface="Arial"/>
               </a:rPr>
-              <a:t>As of Oct 15, 2026</a:t>
+              <a:t>As of Oct 19, 2026</a:t>
             </a:r>
           </a:p>
         </p:txBody>
@@ -33469,7 +33469,7 @@
                 <a:ea typeface="Arial"/>
                 <a:cs typeface="Arial"/>
               </a:rPr>
-              <a:t>As of Oct 15, 2026</a:t>
+              <a:t>As of Oct 19, 2026</a:t>
             </a:r>
           </a:p>
         </p:txBody>
@@ -35011,7 +35011,7 @@
                 <a:ea typeface="Arial"/>
                 <a:cs typeface="Arial"/>
               </a:rPr>
-              <a:t>Planned</a:t>
+              <a:t>In progress</a:t>
             </a:r>
           </a:p>
         </p:txBody>
@@ -35084,7 +35084,7 @@
             <a:avLst/>
           </a:prstGeom>
           <a:solidFill xmlns:a="http://schemas.openxmlformats.org/drawingml/2006/main">
-            <a:srgbClr val="B7BEC4"/>
+            <a:srgbClr val="DCA323"/>
           </a:solidFill>
           <a:ln xmlns:a="http://schemas.openxmlformats.org/drawingml/2006/main" w="0">
             <a:noFill/>
@@ -35640,7 +35640,7 @@
                 <a:ea typeface="Arial"/>
                 <a:cs typeface="Arial"/>
               </a:rPr>
-              <a:t>Planned</a:t>
+              <a:t>In progress</a:t>
             </a:r>
           </a:p>
         </p:txBody>
@@ -35713,7 +35713,7 @@
             <a:avLst/>
           </a:prstGeom>
           <a:solidFill xmlns:a="http://schemas.openxmlformats.org/drawingml/2006/main">
-            <a:srgbClr val="B7BEC4"/>
+            <a:srgbClr val="DCA323"/>
           </a:solidFill>
           <a:ln xmlns:a="http://schemas.openxmlformats.org/drawingml/2006/main" w="0">
             <a:noFill/>
@@ -38100,7 +38100,7 @@
                 <a:ea typeface="Arial"/>
                 <a:cs typeface="Arial"/>
               </a:rPr>
-              <a:t>Planned</a:t>
+              <a:t>In progress</a:t>
             </a:r>
           </a:p>
         </p:txBody>
@@ -38173,7 +38173,7 @@
             <a:avLst/>
           </a:prstGeom>
           <a:solidFill xmlns:a="http://schemas.openxmlformats.org/drawingml/2006/main">
-            <a:srgbClr val="B7BEC4"/>
+            <a:srgbClr val="DCA323"/>
           </a:solidFill>
           <a:ln xmlns:a="http://schemas.openxmlformats.org/drawingml/2006/main" w="0">
             <a:noFill/>
@@ -38701,7 +38701,7 @@
                 <a:ea typeface="Arial"/>
                 <a:cs typeface="Arial"/>
               </a:rPr>
-              <a:t>Planned</a:t>
+              <a:t>In progress</a:t>
             </a:r>
           </a:p>
         </p:txBody>
@@ -38774,7 +38774,7 @@
             <a:avLst/>
           </a:prstGeom>
           <a:solidFill xmlns:a="http://schemas.openxmlformats.org/drawingml/2006/main">
-            <a:srgbClr val="B7BEC4"/>
+            <a:srgbClr val="DCA323"/>
           </a:solidFill>
           <a:ln xmlns:a="http://schemas.openxmlformats.org/drawingml/2006/main" w="0">
             <a:noFill/>
@@ -40010,7 +40010,7 @@
                 <a:ea typeface="Arial"/>
                 <a:cs typeface="Arial"/>
               </a:rPr>
-              <a:t>Planned</a:t>
+              <a:t>In progress</a:t>
             </a:r>
           </a:p>
         </p:txBody>
@@ -40083,7 +40083,7 @@
             <a:avLst/>
           </a:prstGeom>
           <a:solidFill xmlns:a="http://schemas.openxmlformats.org/drawingml/2006/main">
-            <a:srgbClr val="B7BEC4"/>
+            <a:srgbClr val="DCA323"/>
           </a:solidFill>
           <a:ln xmlns:a="http://schemas.openxmlformats.org/drawingml/2006/main" w="0">
             <a:noFill/>

</xml_diff>

<commit_message>
Stage 4 round 1: mRFP control and BioLangFusion Phase A run, Phase B built; sync records, READMEs, Gantt and notes to October 20
Co-Authored-By: Claude Fable 5.1 <noreply@anthropic.com>

Claude-Session: https://claude.ai/code/session_01A54DUp2K2ADqzEJ7zvsPHg
</commit_message>
<xml_diff>
--- a/docs/Research_Project_Plan_Gantt.pptx
+++ b/docs/Research_Project_Plan_Gantt.pptx
@@ -8323,7 +8323,7 @@
                 <a:ea typeface="Arial"/>
                 <a:cs typeface="Arial"/>
               </a:rPr>
-              <a:t>As of Oct 19, 2026</a:t>
+              <a:t>As of Oct 20, 2026</a:t>
             </a:r>
           </a:p>
         </p:txBody>
@@ -32436,7 +32436,7 @@
                 <a:ea typeface="Arial"/>
                 <a:cs typeface="Arial"/>
               </a:rPr>
-              <a:t>As of Oct 19, 2026</a:t>
+              <a:t>As of Oct 20, 2026</a:t>
             </a:r>
           </a:p>
         </p:txBody>
@@ -33469,7 +33469,7 @@
                 <a:ea typeface="Arial"/>
                 <a:cs typeface="Arial"/>
               </a:rPr>
-              <a:t>As of Oct 19, 2026</a:t>
+              <a:t>As of Oct 20, 2026</a:t>
             </a:r>
           </a:p>
         </p:txBody>
@@ -36241,7 +36241,7 @@
                 <a:ea typeface="Arial"/>
                 <a:cs typeface="Arial"/>
               </a:rPr>
-              <a:t>Planned</a:t>
+              <a:t>In progress</a:t>
             </a:r>
           </a:p>
         </p:txBody>
@@ -36314,7 +36314,7 @@
             <a:avLst/>
           </a:prstGeom>
           <a:solidFill xmlns:a="http://schemas.openxmlformats.org/drawingml/2006/main">
-            <a:srgbClr val="B7BEC4"/>
+            <a:srgbClr val="DCA323"/>
           </a:solidFill>
           <a:ln xmlns:a="http://schemas.openxmlformats.org/drawingml/2006/main" w="0">
             <a:noFill/>

</xml_diff>

<commit_message>
Sync the plan, notes, READMEs and deck to the October 22 results
Phase B's four swaps, LucaOne on stability, and the human half-life and
translation-efficiency probes all have results now, so every document that
described them as unrun has been updated.

The finding that changes the account: putting mRNA-FM in the RNA slot
raises E. coli by eight points as a single encoder, resolved, and the +6.9
fusion gain Phase A measured there falls to +0.3 [-2.9, +3.7]. The clearest
fusion win in the project was fusion compensating for a weak encoder.

Gantt: 41 and 42 move to in progress starting October 22; the Details sheet
records what each produced. Notes: the Stage 4 status paragraph, and
questions 2 and 5 rewritten around the new results. Deck: three new slides
for Phase B, LucaOne and the full-transcript tasks, 13 in all.

Co-Authored-By: Claude Fable 5.1 <noreply@anthropic.com>
Claude-Session: https://claude.ai/code/session_01A54DUp2K2ADqzEJ7zvsPHg
</commit_message>
<xml_diff>
--- a/docs/Research_Project_Plan_Gantt.pptx
+++ b/docs/Research_Project_Plan_Gantt.pptx
@@ -8323,7 +8323,7 @@
                 <a:ea typeface="Arial"/>
                 <a:cs typeface="Arial"/>
               </a:rPr>
-              <a:t>As of Oct 20, 2026</a:t>
+              <a:t>As of Oct 22, 2026</a:t>
             </a:r>
           </a:p>
         </p:txBody>
@@ -32436,7 +32436,7 @@
                 <a:ea typeface="Arial"/>
                 <a:cs typeface="Arial"/>
               </a:rPr>
-              <a:t>As of Oct 20, 2026</a:t>
+              <a:t>As of Oct 22, 2026</a:t>
             </a:r>
           </a:p>
         </p:txBody>
@@ -33469,7 +33469,7 @@
                 <a:ea typeface="Arial"/>
                 <a:cs typeface="Arial"/>
               </a:rPr>
-              <a:t>As of Oct 20, 2026</a:t>
+              <a:t>As of Oct 22, 2026</a:t>
             </a:r>
           </a:p>
         </p:txBody>
@@ -38151,7 +38151,7 @@
                 <a:ea typeface="Arial"/>
                 <a:cs typeface="Arial"/>
               </a:rPr>
-              <a:t>11/9-11/22</a:t>
+              <a:t>10/22-11/22</a:t>
             </a:r>
           </a:p>
         </p:txBody>
@@ -38166,8 +38166,8 @@
         </p:nvSpPr>
         <p:spPr>
           <a:xfrm xmlns:a="http://schemas.openxmlformats.org/drawingml/2006/main">
-            <a:off x="8268175" y="2632818"/>
-            <a:ext cx="766000" cy="104775"/>
+            <a:off x="7119175" y="2632818"/>
+            <a:ext cx="1915000" cy="104775"/>
           </a:xfrm>
           <a:prstGeom xmlns:a="http://schemas.openxmlformats.org/drawingml/2006/main" prst="rect">
             <a:avLst/>
@@ -39381,7 +39381,7 @@
                 <a:ea typeface="Arial"/>
                 <a:cs typeface="Arial"/>
               </a:rPr>
-              <a:t>11/23-12/20</a:t>
+              <a:t>10/22-12/20</a:t>
             </a:r>
           </a:p>
         </p:txBody>
@@ -39396,8 +39396,8 @@
         </p:nvSpPr>
         <p:spPr>
           <a:xfrm xmlns:a="http://schemas.openxmlformats.org/drawingml/2006/main">
-            <a:off x="9034175" y="3062002"/>
-            <a:ext cx="1532000" cy="104775"/>
+            <a:off x="7119175" y="3062002"/>
+            <a:ext cx="3447000" cy="104775"/>
           </a:xfrm>
           <a:prstGeom xmlns:a="http://schemas.openxmlformats.org/drawingml/2006/main" prst="rect">
             <a:avLst/>

</xml_diff>

<commit_message>
Docs: Phase B complete (all eight swaps) in deck, guide, notes, run records; new figures
</commit_message>
<xml_diff>
--- a/docs/Research_Project_Plan_Gantt.pptx
+++ b/docs/Research_Project_Plan_Gantt.pptx
@@ -8323,7 +8323,7 @@
                 <a:ea typeface="Arial"/>
                 <a:cs typeface="Arial"/>
               </a:rPr>
-              <a:t>As of Oct 22, 2026</a:t>
+              <a:t>As of Oct 25, 2026</a:t>
             </a:r>
           </a:p>
         </p:txBody>
@@ -32436,7 +32436,7 @@
                 <a:ea typeface="Arial"/>
                 <a:cs typeface="Arial"/>
               </a:rPr>
-              <a:t>As of Oct 22, 2026</a:t>
+              <a:t>As of Oct 25, 2026</a:t>
             </a:r>
           </a:p>
         </p:txBody>
@@ -33469,7 +33469,7 @@
                 <a:ea typeface="Arial"/>
                 <a:cs typeface="Arial"/>
               </a:rPr>
-              <a:t>As of Oct 22, 2026</a:t>
+              <a:t>As of Oct 25, 2026</a:t>
             </a:r>
           </a:p>
         </p:txBody>

</xml_diff>